<commit_message>
docs: update official 3-member team details across README, docs, PPT, and UI
</commit_message>
<xml_diff>
--- a/RecapRoom_AI_Presentation.pptx
+++ b/RecapRoom_AI_Presentation.pptx
@@ -3265,8 +3265,8 @@
         </p:nvSpPr>
         <p:spPr>
           <a:xfrm>
-            <a:off x="914400" y="4754880"/>
-            <a:ext cx="10332720" cy="1280160"/>
+            <a:off x="914400" y="4572000"/>
+            <a:ext cx="10332720" cy="1645920"/>
           </a:xfrm>
           <a:prstGeom prst="roundRect">
             <a:avLst/>
@@ -3295,7 +3295,7 @@
           </a:fontRef>
         </p:style>
         <p:txBody>
-          <a:bodyPr rtlCol="0" anchor="ctr" lIns="365760" tIns="228600"/>
+          <a:bodyPr rtlCol="0" anchor="ctr" lIns="365760" tIns="182880"/>
           <a:lstStyle/>
           <a:p>
             <a:pPr algn="ctr">
@@ -3306,22 +3306,37 @@
               </a:defRPr>
             </a:pPr>
             <a:r>
-              <a:t>Target Users: Students, Agile Software Teams, Project Coordinators</a:t>
+              <a:t>Team Members: Jammu Dinesh (23341A05A3) · Manish Sharma (23341A05F7) · Mohammed Ajad (23341A05G3)</a:t>
             </a:r>
           </a:p>
           <a:p>
             <a:pPr>
               <a:spcBef>
-                <a:spcPts val="600"/>
+                <a:spcPts val="400"/>
               </a:spcBef>
-              <a:defRPr sz="1200">
+              <a:defRPr sz="1200" b="1">
+                <a:solidFill>
+                  <a:srgbClr val="FF4B4B"/>
+                </a:solidFill>
+              </a:defRPr>
+            </a:pPr>
+            <a:r>
+              <a:t>GMR Institute of Technology (GMRIT) — Department of Computer Science &amp; Engineering</a:t>
+            </a:r>
+          </a:p>
+          <a:p>
+            <a:pPr>
+              <a:spcBef>
+                <a:spcPts val="400"/>
+              </a:spcBef>
+              <a:defRPr sz="1100">
                 <a:solidFill>
                   <a:srgbClr val="94A3B8"/>
                 </a:solidFill>
               </a:defRPr>
             </a:pPr>
             <a:r>
-              <a:t>Tech Stack: Streamlit 1.40 | Python 3.12 | Pydantic v2 | Groq API (Llama 3.3) | Google Gemini | Offline Rule Engine</a:t>
+              <a:t>Target Users: Students, Agile Teams, Coordinators | Stack: Streamlit 1.40 · Python 3.12 · Pydantic v2 · Groq · Gemini</a:t>
             </a:r>
           </a:p>
         </p:txBody>
@@ -5822,7 +5837,7 @@
               </a:defRPr>
             </a:pPr>
             <a:r>
-              <a:t>• GitHub Repository: Ready for submission (clean modular codebase, zero secrets committed)</a:t>
+              <a:t>• Project Team: Jammu Dinesh (23341A05A3), Manish Sharma (23341A05F7), Mohammed Ajad (23341A05G3) — GMRIT</a:t>
             </a:r>
           </a:p>
           <a:p>
@@ -5837,7 +5852,7 @@
               </a:defRPr>
             </a:pPr>
             <a:r>
-              <a:t>• Streamlit Community Cloud: Deployed app with 1-click Demo Mode (no key required for evaluator)</a:t>
+              <a:t>• GitHub Repository: https://github.com/ajad12345/recaproom-ai</a:t>
             </a:r>
           </a:p>
           <a:p>
@@ -5852,7 +5867,7 @@
               </a:defRPr>
             </a:pPr>
             <a:r>
-              <a:t>• Technical Documentation: docs/project_report.md &amp; docs/deployment_guide.md included</a:t>
+              <a:t>• Streamlit Community Cloud: Deployed app with 1-click Demo Mode (no key required for evaluator)</a:t>
             </a:r>
           </a:p>
           <a:p>
@@ -5867,7 +5882,7 @@
               </a:defRPr>
             </a:pPr>
             <a:r>
-              <a:t>• Test Suite Verification: 55 tests passing locally and in CI/CD pipeline</a:t>
+              <a:t>• Test Suite Verification: 55 automated tests passing locally and in CI/CD pipeline</a:t>
             </a:r>
           </a:p>
         </p:txBody>

</xml_diff>